<commit_message>
Expand story presentation to 9 slides
Co-Authored-By: Claude Opus 5.5 <noreply@anthropic.com>
Claude-Session: https://claude.ai/code/session_01L2BPhv8XRptUJjqx8ss27u
</commit_message>
<xml_diff>
--- a/Toby y la pelota roja.pptx
+++ b/Toby y la pelota roja.pptx
@@ -11,9 +11,12 @@
     <p:sldId id="259" r:id="rId5"/>
     <p:sldId id="260" r:id="rId6"/>
     <p:sldId id="261" r:id="rId7"/>
+    <p:sldId id="262" r:id="rId8"/>
+    <p:sldId id="263" r:id="rId9"/>
+    <p:sldId id="264" r:id="rId10"/>
   </p:sldIdLst>
   <p:notesMasterIdLst>
-    <p:notesMasterId r:id="rId8"/>
+    <p:notesMasterId r:id="rId11"/>
   </p:notesMasterIdLst>
   <p:sldSz cx="9144000" cy="5486400"/>
   <p:notesSz cx="5486400" cy="9144000"/>
@@ -971,6 +974,270 @@
             <a:fld id="{F7021451-1387-4CA6-816F-3879F97B5CBC}" type="slidenum">
               <a:rPr lang="en-US"/>
               <a:t>6</a:t>
+            </a:fld>
+            <a:endParaRPr lang="en-US"/>
+          </a:p>
+        </p:txBody>
+      </p:sp>
+    </p:spTree>
+    <p:extLst>
+      <p:ext uri="{BB962C8B-B14F-4D97-AF65-F5344CB8AC3E}">
+        <p14:creationId xmlns:p14="http://schemas.microsoft.com/office/powerpoint/2010/main" val="1024086991"/>
+      </p:ext>
+    </p:extLst>
+  </p:cSld>
+  <p:clrMapOvr>
+    <a:masterClrMapping/>
+  </p:clrMapOvr>
+</p:notes>
+</file>
+
+<file path=ppt/notesSlides/notesSlide7.xml><?xml version="1.0" encoding="utf-8"?>
+<p:notes xmlns:a="http://schemas.openxmlformats.org/drawingml/2006/main" xmlns:r="http://schemas.openxmlformats.org/officeDocument/2006/relationships" xmlns:p="http://schemas.openxmlformats.org/presentationml/2006/main">
+  <p:cSld>
+    <p:spTree>
+      <p:nvGrpSpPr>
+        <p:cNvPr id="1" name=""/>
+        <p:cNvGrpSpPr/>
+        <p:nvPr/>
+      </p:nvGrpSpPr>
+      <p:grpSpPr>
+        <a:xfrm>
+          <a:off x="0" y="0"/>
+          <a:ext cx="0" cy="0"/>
+          <a:chOff x="0" y="0"/>
+          <a:chExt cx="0" cy="0"/>
+        </a:xfrm>
+      </p:grpSpPr>
+      <p:sp>
+        <p:nvSpPr>
+          <p:cNvPr id="2" name="Slide Image Placeholder 1"/>
+          <p:cNvSpPr>
+            <a:spLocks noGrp="1" noRot="1" noChangeAspect="1"/>
+          </p:cNvSpPr>
+          <p:nvPr>
+            <p:ph type="sldImg"/>
+          </p:nvPr>
+        </p:nvSpPr>
+        <p:spPr/>
+      </p:sp>
+      <p:sp>
+        <p:nvSpPr>
+          <p:cNvPr id="3" name="Notes Placeholder 2"/>
+          <p:cNvSpPr>
+            <a:spLocks noGrp="1"/>
+          </p:cNvSpPr>
+          <p:nvPr>
+            <p:ph type="body" idx="1"/>
+          </p:nvPr>
+        </p:nvSpPr>
+        <p:spPr/>
+        <p:txBody>
+          <a:bodyPr/>
+          <a:lstStyle/>
+          <a:p>
+            <a:r>
+              <a:rPr lang="en-US" dirty="0"/>
+              <a:t/>
+            </a:r>
+            <a:endParaRPr lang="en-US" dirty="0"/>
+          </a:p>
+        </p:txBody>
+      </p:sp>
+      <p:sp>
+        <p:nvSpPr>
+          <p:cNvPr id="4" name="Slide Number Placeholder 3"/>
+          <p:cNvSpPr>
+            <a:spLocks noGrp="1"/>
+          </p:cNvSpPr>
+          <p:nvPr>
+            <p:ph type="sldNum" sz="quarter" idx="10"/>
+          </p:nvPr>
+        </p:nvSpPr>
+        <p:spPr/>
+        <p:txBody>
+          <a:bodyPr/>
+          <a:lstStyle/>
+          <a:p>
+            <a:fld id="{F7021451-1387-4CA6-816F-3879F97B5CBC}" type="slidenum">
+              <a:rPr lang="en-US"/>
+              <a:t>7</a:t>
+            </a:fld>
+            <a:endParaRPr lang="en-US"/>
+          </a:p>
+        </p:txBody>
+      </p:sp>
+    </p:spTree>
+    <p:extLst>
+      <p:ext uri="{BB962C8B-B14F-4D97-AF65-F5344CB8AC3E}">
+        <p14:creationId xmlns:p14="http://schemas.microsoft.com/office/powerpoint/2010/main" val="1024086991"/>
+      </p:ext>
+    </p:extLst>
+  </p:cSld>
+  <p:clrMapOvr>
+    <a:masterClrMapping/>
+  </p:clrMapOvr>
+</p:notes>
+</file>
+
+<file path=ppt/notesSlides/notesSlide8.xml><?xml version="1.0" encoding="utf-8"?>
+<p:notes xmlns:a="http://schemas.openxmlformats.org/drawingml/2006/main" xmlns:r="http://schemas.openxmlformats.org/officeDocument/2006/relationships" xmlns:p="http://schemas.openxmlformats.org/presentationml/2006/main">
+  <p:cSld>
+    <p:spTree>
+      <p:nvGrpSpPr>
+        <p:cNvPr id="1" name=""/>
+        <p:cNvGrpSpPr/>
+        <p:nvPr/>
+      </p:nvGrpSpPr>
+      <p:grpSpPr>
+        <a:xfrm>
+          <a:off x="0" y="0"/>
+          <a:ext cx="0" cy="0"/>
+          <a:chOff x="0" y="0"/>
+          <a:chExt cx="0" cy="0"/>
+        </a:xfrm>
+      </p:grpSpPr>
+      <p:sp>
+        <p:nvSpPr>
+          <p:cNvPr id="2" name="Slide Image Placeholder 1"/>
+          <p:cNvSpPr>
+            <a:spLocks noGrp="1" noRot="1" noChangeAspect="1"/>
+          </p:cNvSpPr>
+          <p:nvPr>
+            <p:ph type="sldImg"/>
+          </p:nvPr>
+        </p:nvSpPr>
+        <p:spPr/>
+      </p:sp>
+      <p:sp>
+        <p:nvSpPr>
+          <p:cNvPr id="3" name="Notes Placeholder 2"/>
+          <p:cNvSpPr>
+            <a:spLocks noGrp="1"/>
+          </p:cNvSpPr>
+          <p:nvPr>
+            <p:ph type="body" idx="1"/>
+          </p:nvPr>
+        </p:nvSpPr>
+        <p:spPr/>
+        <p:txBody>
+          <a:bodyPr/>
+          <a:lstStyle/>
+          <a:p>
+            <a:r>
+              <a:rPr lang="en-US" dirty="0"/>
+              <a:t/>
+            </a:r>
+            <a:endParaRPr lang="en-US" dirty="0"/>
+          </a:p>
+        </p:txBody>
+      </p:sp>
+      <p:sp>
+        <p:nvSpPr>
+          <p:cNvPr id="4" name="Slide Number Placeholder 3"/>
+          <p:cNvSpPr>
+            <a:spLocks noGrp="1"/>
+          </p:cNvSpPr>
+          <p:nvPr>
+            <p:ph type="sldNum" sz="quarter" idx="10"/>
+          </p:nvPr>
+        </p:nvSpPr>
+        <p:spPr/>
+        <p:txBody>
+          <a:bodyPr/>
+          <a:lstStyle/>
+          <a:p>
+            <a:fld id="{F7021451-1387-4CA6-816F-3879F97B5CBC}" type="slidenum">
+              <a:rPr lang="en-US"/>
+              <a:t>8</a:t>
+            </a:fld>
+            <a:endParaRPr lang="en-US"/>
+          </a:p>
+        </p:txBody>
+      </p:sp>
+    </p:spTree>
+    <p:extLst>
+      <p:ext uri="{BB962C8B-B14F-4D97-AF65-F5344CB8AC3E}">
+        <p14:creationId xmlns:p14="http://schemas.microsoft.com/office/powerpoint/2010/main" val="1024086991"/>
+      </p:ext>
+    </p:extLst>
+  </p:cSld>
+  <p:clrMapOvr>
+    <a:masterClrMapping/>
+  </p:clrMapOvr>
+</p:notes>
+</file>
+
+<file path=ppt/notesSlides/notesSlide9.xml><?xml version="1.0" encoding="utf-8"?>
+<p:notes xmlns:a="http://schemas.openxmlformats.org/drawingml/2006/main" xmlns:r="http://schemas.openxmlformats.org/officeDocument/2006/relationships" xmlns:p="http://schemas.openxmlformats.org/presentationml/2006/main">
+  <p:cSld>
+    <p:spTree>
+      <p:nvGrpSpPr>
+        <p:cNvPr id="1" name=""/>
+        <p:cNvGrpSpPr/>
+        <p:nvPr/>
+      </p:nvGrpSpPr>
+      <p:grpSpPr>
+        <a:xfrm>
+          <a:off x="0" y="0"/>
+          <a:ext cx="0" cy="0"/>
+          <a:chOff x="0" y="0"/>
+          <a:chExt cx="0" cy="0"/>
+        </a:xfrm>
+      </p:grpSpPr>
+      <p:sp>
+        <p:nvSpPr>
+          <p:cNvPr id="2" name="Slide Image Placeholder 1"/>
+          <p:cNvSpPr>
+            <a:spLocks noGrp="1" noRot="1" noChangeAspect="1"/>
+          </p:cNvSpPr>
+          <p:nvPr>
+            <p:ph type="sldImg"/>
+          </p:nvPr>
+        </p:nvSpPr>
+        <p:spPr/>
+      </p:sp>
+      <p:sp>
+        <p:nvSpPr>
+          <p:cNvPr id="3" name="Notes Placeholder 2"/>
+          <p:cNvSpPr>
+            <a:spLocks noGrp="1"/>
+          </p:cNvSpPr>
+          <p:nvPr>
+            <p:ph type="body" idx="1"/>
+          </p:nvPr>
+        </p:nvSpPr>
+        <p:spPr/>
+        <p:txBody>
+          <a:bodyPr/>
+          <a:lstStyle/>
+          <a:p>
+            <a:r>
+              <a:rPr lang="en-US" dirty="0"/>
+              <a:t/>
+            </a:r>
+            <a:endParaRPr lang="en-US" dirty="0"/>
+          </a:p>
+        </p:txBody>
+      </p:sp>
+      <p:sp>
+        <p:nvSpPr>
+          <p:cNvPr id="4" name="Slide Number Placeholder 3"/>
+          <p:cNvSpPr>
+            <a:spLocks noGrp="1"/>
+          </p:cNvSpPr>
+          <p:nvPr>
+            <p:ph type="sldNum" sz="quarter" idx="10"/>
+          </p:nvPr>
+        </p:nvSpPr>
+        <p:spPr/>
+        <p:txBody>
+          <a:bodyPr/>
+          <a:lstStyle/>
+          <a:p>
+            <a:fld id="{F7021451-1387-4CA6-816F-3879F97B5CBC}" type="slidenum">
+              <a:rPr lang="en-US"/>
+              <a:t>9</a:t>
             </a:fld>
             <a:endParaRPr lang="en-US"/>
           </a:p>
@@ -2072,6 +2339,379 @@
       </p:pic>
       <p:pic>
         <p:nvPicPr>
+          <p:cNvPr id="3" name="dog" descr="Toby, un perro corgi">    </p:cNvPr>
+          <p:cNvPicPr>
+            <a:picLocks noChangeAspect="1"/>
+          </p:cNvPicPr>
+          <p:nvPr/>
+        </p:nvPicPr>
+        <p:blipFill>
+          <a:blip r:embed="rId3"/>
+          <a:stretch>
+            <a:fillRect/>
+          </a:stretch>
+        </p:blipFill>
+        <p:spPr>
+          <a:xfrm>
+            <a:off x="2384971" y="1892528"/>
+            <a:ext cx="2742234" cy="3157432"/>
+          </a:xfrm>
+          <a:prstGeom prst="rect">
+            <a:avLst/>
+          </a:prstGeom>
+        </p:spPr>
+      </p:pic>
+      <p:pic>
+        <p:nvPicPr>
+          <p:cNvPr id="4" name="grass" descr="Pasto">    </p:cNvPr>
+          <p:cNvPicPr>
+            <a:picLocks noChangeAspect="1"/>
+          </p:cNvPicPr>
+          <p:nvPr/>
+        </p:nvPicPr>
+        <p:blipFill>
+          <a:blip r:embed="rId4"/>
+          <a:stretch>
+            <a:fillRect/>
+          </a:stretch>
+        </p:blipFill>
+        <p:spPr>
+          <a:xfrm>
+            <a:off x="0" y="4258188"/>
+            <a:ext cx="9144000" cy="1226281"/>
+          </a:xfrm>
+          <a:prstGeom prst="rect">
+            <a:avLst/>
+          </a:prstGeom>
+        </p:spPr>
+      </p:pic>
+      <p:sp>
+        <p:nvSpPr>
+          <p:cNvPr id="5" name="card"/>
+          <p:cNvSpPr txBox="1"/>
+          <p:nvPr/>
+        </p:nvSpPr>
+        <p:spPr>
+          <a:xfrm>
+            <a:off x="365760" y="320040"/>
+            <a:ext cx="4206240" cy="1234440"/>
+          </a:xfrm>
+          <a:prstGeom prst="roundRect">
+            <a:avLst>
+              <a:gd name="adj" fmla="val 14815"/>
+            </a:avLst>
+          </a:prstGeom>
+          <a:solidFill>
+            <a:srgbClr val="FFFFFF">
+              <a:alpha val="92000"/>
+            </a:srgbClr>
+          </a:solidFill>
+          <a:ln/>
+          <a:effectLst>
+            <a:outerShdw sx="100000" sy="100000" kx="0" ky="0" algn="bl" rotWithShape="0" blurRad="76200" dist="25400" dir="5400000">
+              <a:srgbClr val="000000">
+                <a:alpha val="18000"/>
+              </a:srgbClr>
+            </a:outerShdw>
+          </a:effectLst>
+        </p:spPr>
+        <p:txBody>
+          <a:bodyPr wrap="square" lIns="127000" tIns="203200" rIns="203200" bIns="127000" rtlCol="0" anchor="ctr"/>
+          <a:lstStyle/>
+          <a:p>
+            <a:pPr indent="0" marL="0">
+              <a:buNone/>
+            </a:pPr>
+            <a:r>
+              <a:rPr lang="en-US" sz="2000" dirty="0">
+                <a:solidFill>
+                  <a:srgbClr val="3B2A20"/>
+                </a:solidFill>
+                <a:latin typeface="Arial" pitchFamily="34" charset="0"/>
+                <a:ea typeface="Arial" pitchFamily="34" charset="-122"/>
+                <a:cs typeface="Arial" pitchFamily="34" charset="-120"/>
+              </a:rPr>
+              <a:t>Pero Toby casi nunca salía a jugar. Pasaba el día echado, aburrido y </a:t>
+            </a:r>
+            <a:pPr indent="0" marL="0">
+              <a:buNone/>
+            </a:pPr>
+            <a:r>
+              <a:rPr lang="en-US" sz="2000" b="1" dirty="0">
+                <a:solidFill>
+                  <a:srgbClr val="E0702A"/>
+                </a:solidFill>
+                <a:latin typeface="Arial" pitchFamily="34" charset="0"/>
+                <a:ea typeface="Arial" pitchFamily="34" charset="-122"/>
+                <a:cs typeface="Arial" pitchFamily="34" charset="-120"/>
+              </a:rPr>
+              <a:t>sin energía</a:t>
+            </a:r>
+            <a:pPr indent="0" marL="0">
+              <a:buNone/>
+            </a:pPr>
+            <a:r>
+              <a:rPr lang="en-US" sz="2000" dirty="0">
+                <a:solidFill>
+                  <a:srgbClr val="3B2A20"/>
+                </a:solidFill>
+                <a:latin typeface="Arial" pitchFamily="34" charset="0"/>
+                <a:ea typeface="Arial" pitchFamily="34" charset="-122"/>
+                <a:cs typeface="Arial" pitchFamily="34" charset="-120"/>
+              </a:rPr>
+              <a:t>.</a:t>
+            </a:r>
+            <a:endParaRPr lang="en-US" sz="2000" dirty="0"/>
+          </a:p>
+        </p:txBody>
+      </p:sp>
+      <p:sp>
+        <p:nvSpPr>
+          <p:cNvPr id="6" name="bubble"/>
+          <p:cNvSpPr txBox="1"/>
+          <p:nvPr/>
+        </p:nvSpPr>
+        <p:spPr>
+          <a:xfrm>
+            <a:off x="4663440" y="1417320"/>
+            <a:ext cx="1737360" cy="777240"/>
+          </a:xfrm>
+          <a:prstGeom prst="ellipse">
+            <a:avLst/>
+          </a:prstGeom>
+          <a:solidFill>
+            <a:srgbClr val="FFFFFF"/>
+          </a:solidFill>
+          <a:ln w="25400">
+            <a:solidFill>
+              <a:srgbClr val="E0702A"/>
+            </a:solidFill>
+          </a:ln>
+        </p:spPr>
+        <p:txBody>
+          <a:bodyPr wrap="square" rtlCol="0" anchor="ctr"/>
+          <a:lstStyle/>
+          <a:p>
+            <a:pPr algn="ctr" indent="0" marL="0">
+              <a:buNone/>
+            </a:pPr>
+            <a:r>
+              <a:rPr lang="en-US" sz="2000" b="1" dirty="0">
+                <a:solidFill>
+                  <a:srgbClr val="E0702A"/>
+                </a:solidFill>
+                <a:latin typeface="Arial" pitchFamily="34" charset="0"/>
+                <a:ea typeface="Arial" pitchFamily="34" charset="-122"/>
+                <a:cs typeface="Arial" pitchFamily="34" charset="-120"/>
+              </a:rPr>
+              <a:t>Zzz…</a:t>
+            </a:r>
+            <a:endParaRPr lang="en-US" sz="2000" dirty="0"/>
+          </a:p>
+        </p:txBody>
+      </p:sp>
+    </p:spTree>
+  </p:cSld>
+  <p:clrMapOvr>
+    <a:masterClrMapping/>
+  </p:clrMapOvr>
+  <p:transition spd="med">
+    <p:fade/>
+  </p:transition>
+  <p:timing>
+    <p:tnLst>
+      <p:par>
+        <p:cTn id="1" dur="indefinite" restart="never" nodeType="tmRoot">
+          <p:childTnLst>
+            <p:seq concurrent="1" nextAc="seek">
+              <p:cTn id="2" dur="indefinite" nodeType="mainSeq">
+                <p:childTnLst>
+                  <p:par>
+                    <p:cTn id="3" fill="hold">
+                      <p:stCondLst>
+                        <p:cond delay="indefinite"/>
+                        <p:cond evt="onBegin" delay="0">
+                          <p:tn val="2"/>
+                        </p:cond>
+                      </p:stCondLst>
+                      <p:childTnLst>
+                        <p:par>
+                          <p:cTn id="7" fill="hold">
+                            <p:stCondLst>
+                              <p:cond delay="0"/>
+                            </p:stCondLst>
+                            <p:childTnLst>
+                              <p:par>
+                                <p:cTn id="4" presetID="10" presetClass="entr" presetSubtype="0" fill="hold" grpId="0" nodeType="afterEffect">
+                                  <p:stCondLst>
+                                    <p:cond delay="0"/>
+                                  </p:stCondLst>
+                                  <p:childTnLst>
+                                    <p:set>
+                                      <p:cBhvr>
+                                        <p:cTn id="5" dur="1" fill="hold">
+                                          <p:stCondLst>
+                                            <p:cond delay="0"/>
+                                          </p:stCondLst>
+                                        </p:cTn>
+                                        <p:tgtEl>
+                                          <p:spTgt spid="5"/>
+                                        </p:tgtEl>
+                                        <p:attrNameLst>
+                                          <p:attrName>style.visibility</p:attrName>
+                                        </p:attrNameLst>
+                                      </p:cBhvr>
+                                      <p:to>
+                                        <p:strVal val="visible"/>
+                                      </p:to>
+                                    </p:set>
+                                    <p:animEffect transition="in" filter="fade">
+                                      <p:cBhvr>
+                                        <p:cTn id="6" dur="900"/>
+                                        <p:tgtEl>
+                                          <p:spTgt spid="5"/>
+                                        </p:tgtEl>
+                                      </p:cBhvr>
+                                    </p:animEffect>
+                                  </p:childTnLst>
+                                </p:cTn>
+                              </p:par>
+                            </p:childTnLst>
+                          </p:cTn>
+                        </p:par>
+                        <p:par>
+                          <p:cTn id="11" fill="hold">
+                            <p:stCondLst>
+                              <p:cond delay="1150"/>
+                            </p:stCondLst>
+                            <p:childTnLst>
+                              <p:par>
+                                <p:cTn id="8" presetID="10" presetClass="entr" presetSubtype="0" fill="hold" grpId="0" nodeType="afterEffect">
+                                  <p:stCondLst>
+                                    <p:cond delay="0"/>
+                                  </p:stCondLst>
+                                  <p:childTnLst>
+                                    <p:set>
+                                      <p:cBhvr>
+                                        <p:cTn id="9" dur="1" fill="hold">
+                                          <p:stCondLst>
+                                            <p:cond delay="0"/>
+                                          </p:stCondLst>
+                                        </p:cTn>
+                                        <p:tgtEl>
+                                          <p:spTgt spid="6"/>
+                                        </p:tgtEl>
+                                        <p:attrNameLst>
+                                          <p:attrName>style.visibility</p:attrName>
+                                        </p:attrNameLst>
+                                      </p:cBhvr>
+                                      <p:to>
+                                        <p:strVal val="visible"/>
+                                      </p:to>
+                                    </p:set>
+                                    <p:animEffect transition="in" filter="fade">
+                                      <p:cBhvr>
+                                        <p:cTn id="10" dur="900"/>
+                                        <p:tgtEl>
+                                          <p:spTgt spid="6"/>
+                                        </p:tgtEl>
+                                      </p:cBhvr>
+                                    </p:animEffect>
+                                  </p:childTnLst>
+                                </p:cTn>
+                              </p:par>
+                            </p:childTnLst>
+                          </p:cTn>
+                        </p:par>
+                      </p:childTnLst>
+                    </p:cTn>
+                  </p:par>
+                </p:childTnLst>
+              </p:cTn>
+              <p:prevCondLst>
+                <p:cond evt="onPrev" delay="0">
+                  <p:tgtEl>
+                    <p:sldTgt/>
+                  </p:tgtEl>
+                </p:cond>
+              </p:prevCondLst>
+              <p:nextCondLst>
+                <p:cond evt="onNext" delay="0">
+                  <p:tgtEl>
+                    <p:sldTgt/>
+                  </p:tgtEl>
+                </p:cond>
+              </p:nextCondLst>
+            </p:seq>
+          </p:childTnLst>
+        </p:cTn>
+      </p:par>
+    </p:tnLst>
+    <p:bldLst>
+      <p:bldP spid="5" grpId="0" animBg="1"/>
+      <p:bldP spid="6" grpId="0" animBg="1"/>
+    </p:bldLst>
+  </p:timing>
+</p:sld>
+</file>
+
+<file path=ppt/slides/slide4.xml><?xml version="1.0" encoding="utf-8"?>
+<p:sld xmlns:a="http://schemas.openxmlformats.org/drawingml/2006/main" xmlns:r="http://schemas.openxmlformats.org/officeDocument/2006/relationships" xmlns:p="http://schemas.openxmlformats.org/presentationml/2006/main">
+  <p:cSld name="Slide 4">
+    <p:bg>
+      <p:bgPr>
+        <a:blipFill dpi="0" rotWithShape="1">
+          <a:blip r:embed="rId1">
+            <a:lum/>
+          </a:blip>
+          <a:srcRect/>
+          <a:stretch>
+            <a:fillRect/>
+          </a:stretch>
+        </a:blipFill>
+        <a:effectLst/>
+      </p:bgPr>
+    </p:bg>
+    <p:spTree>
+      <p:nvGrpSpPr>
+        <p:cNvPr id="1" name=""/>
+        <p:cNvGrpSpPr/>
+        <p:nvPr/>
+      </p:nvGrpSpPr>
+      <p:grpSpPr>
+        <a:xfrm>
+          <a:off x="0" y="0"/>
+          <a:ext cx="0" cy="0"/>
+          <a:chOff x="0" y="0"/>
+          <a:chExt cx="0" cy="0"/>
+        </a:xfrm>
+      </p:grpSpPr>
+      <p:pic>
+        <p:nvPicPr>
+          <p:cNvPr id="2" name="trees" descr="Árbol y arbusto">    </p:cNvPr>
+          <p:cNvPicPr>
+            <a:picLocks noChangeAspect="1"/>
+          </p:cNvPicPr>
+          <p:nvPr/>
+        </p:nvPicPr>
+        <p:blipFill>
+          <a:blip r:embed="rId2"/>
+          <a:stretch>
+            <a:fillRect/>
+          </a:stretch>
+        </p:blipFill>
+        <p:spPr>
+          <a:xfrm>
+            <a:off x="3765744" y="0"/>
+            <a:ext cx="5194796" cy="4992025"/>
+          </a:xfrm>
+          <a:prstGeom prst="rect">
+            <a:avLst/>
+          </a:prstGeom>
+        </p:spPr>
+      </p:pic>
+      <p:pic>
+        <p:nvPicPr>
           <p:cNvPr id="3" name="ball" descr="Pelota roja">    </p:cNvPr>
           <p:cNvPicPr>
             <a:picLocks noChangeAspect="1"/>
@@ -2514,9 +3154,9 @@
 </p:sld>
 </file>
 
-<file path=ppt/slides/slide4.xml><?xml version="1.0" encoding="utf-8"?>
+<file path=ppt/slides/slide5.xml><?xml version="1.0" encoding="utf-8"?>
 <p:sld xmlns:a="http://schemas.openxmlformats.org/drawingml/2006/main" xmlns:r="http://schemas.openxmlformats.org/officeDocument/2006/relationships" xmlns:p="http://schemas.openxmlformats.org/presentationml/2006/main">
-  <p:cSld name="Slide 4">
+  <p:cSld name="Slide 5">
     <p:bg>
       <p:bgPr>
         <a:blipFill dpi="0" rotWithShape="1">
@@ -2904,9 +3544,443 @@
 </p:sld>
 </file>
 
-<file path=ppt/slides/slide5.xml><?xml version="1.0" encoding="utf-8"?>
+<file path=ppt/slides/slide6.xml><?xml version="1.0" encoding="utf-8"?>
 <p:sld xmlns:a="http://schemas.openxmlformats.org/drawingml/2006/main" xmlns:r="http://schemas.openxmlformats.org/officeDocument/2006/relationships" xmlns:p="http://schemas.openxmlformats.org/presentationml/2006/main">
-  <p:cSld name="Slide 5">
+  <p:cSld name="Slide 6">
+    <p:bg>
+      <p:bgPr>
+        <a:blipFill dpi="0" rotWithShape="1">
+          <a:blip r:embed="rId1">
+            <a:lum/>
+          </a:blip>
+          <a:srcRect/>
+          <a:stretch>
+            <a:fillRect/>
+          </a:stretch>
+        </a:blipFill>
+        <a:effectLst/>
+      </p:bgPr>
+    </p:bg>
+    <p:spTree>
+      <p:nvGrpSpPr>
+        <p:cNvPr id="1" name=""/>
+        <p:cNvGrpSpPr/>
+        <p:nvPr/>
+      </p:nvGrpSpPr>
+      <p:grpSpPr>
+        <a:xfrm>
+          <a:off x="0" y="0"/>
+          <a:ext cx="0" cy="0"/>
+          <a:chOff x="0" y="0"/>
+          <a:chExt cx="0" cy="0"/>
+        </a:xfrm>
+      </p:grpSpPr>
+      <p:pic>
+        <p:nvPicPr>
+          <p:cNvPr id="2" name="trees" descr="Árbol y arbusto">    </p:cNvPr>
+          <p:cNvPicPr>
+            <a:picLocks noChangeAspect="1"/>
+          </p:cNvPicPr>
+          <p:nvPr/>
+        </p:nvPicPr>
+        <p:blipFill>
+          <a:blip r:embed="rId2"/>
+          <a:stretch>
+            <a:fillRect/>
+          </a:stretch>
+        </p:blipFill>
+        <p:spPr>
+          <a:xfrm>
+            <a:off x="3765744" y="0"/>
+            <a:ext cx="5194796" cy="4992025"/>
+          </a:xfrm>
+          <a:prstGeom prst="rect">
+            <a:avLst/>
+          </a:prstGeom>
+        </p:spPr>
+      </p:pic>
+      <p:pic>
+        <p:nvPicPr>
+          <p:cNvPr id="3" name="ball" descr="Pelota roja">    </p:cNvPr>
+          <p:cNvPicPr>
+            <a:picLocks noChangeAspect="1"/>
+          </p:cNvPicPr>
+          <p:nvPr/>
+        </p:nvPicPr>
+        <p:blipFill>
+          <a:blip r:embed="rId3"/>
+          <a:stretch>
+            <a:fillRect/>
+          </a:stretch>
+        </p:blipFill>
+        <p:spPr>
+          <a:xfrm>
+            <a:off x="5257800" y="2651760"/>
+            <a:ext cx="608313" cy="608313"/>
+          </a:xfrm>
+          <a:prstGeom prst="rect">
+            <a:avLst/>
+          </a:prstGeom>
+        </p:spPr>
+      </p:pic>
+      <p:pic>
+        <p:nvPicPr>
+          <p:cNvPr id="4" name="dog" descr="Toby, un perro corgi">    </p:cNvPr>
+          <p:cNvPicPr>
+            <a:picLocks noChangeAspect="1"/>
+          </p:cNvPicPr>
+          <p:nvPr/>
+        </p:nvPicPr>
+        <p:blipFill>
+          <a:blip r:embed="rId4"/>
+          <a:stretch>
+            <a:fillRect/>
+          </a:stretch>
+        </p:blipFill>
+        <p:spPr>
+          <a:xfrm>
+            <a:off x="2384971" y="1645920"/>
+            <a:ext cx="2742234" cy="3157432"/>
+          </a:xfrm>
+          <a:prstGeom prst="rect">
+            <a:avLst/>
+          </a:prstGeom>
+        </p:spPr>
+      </p:pic>
+      <p:pic>
+        <p:nvPicPr>
+          <p:cNvPr id="5" name="grass" descr="Pasto">    </p:cNvPr>
+          <p:cNvPicPr>
+            <a:picLocks noChangeAspect="1"/>
+          </p:cNvPicPr>
+          <p:nvPr/>
+        </p:nvPicPr>
+        <p:blipFill>
+          <a:blip r:embed="rId5"/>
+          <a:stretch>
+            <a:fillRect/>
+          </a:stretch>
+        </p:blipFill>
+        <p:spPr>
+          <a:xfrm>
+            <a:off x="0" y="4258188"/>
+            <a:ext cx="9144000" cy="1226281"/>
+          </a:xfrm>
+          <a:prstGeom prst="rect">
+            <a:avLst/>
+          </a:prstGeom>
+        </p:spPr>
+      </p:pic>
+      <p:sp>
+        <p:nvSpPr>
+          <p:cNvPr id="6" name="card"/>
+          <p:cNvSpPr txBox="1"/>
+          <p:nvPr/>
+        </p:nvSpPr>
+        <p:spPr>
+          <a:xfrm>
+            <a:off x="365760" y="320040"/>
+            <a:ext cx="4206240" cy="1234440"/>
+          </a:xfrm>
+          <a:prstGeom prst="roundRect">
+            <a:avLst>
+              <a:gd name="adj" fmla="val 14815"/>
+            </a:avLst>
+          </a:prstGeom>
+          <a:solidFill>
+            <a:srgbClr val="FFFFFF">
+              <a:alpha val="92000"/>
+            </a:srgbClr>
+          </a:solidFill>
+          <a:ln/>
+          <a:effectLst>
+            <a:outerShdw sx="100000" sy="100000" kx="0" ky="0" algn="bl" rotWithShape="0" blurRad="76200" dist="25400" dir="5400000">
+              <a:srgbClr val="000000">
+                <a:alpha val="18000"/>
+              </a:srgbClr>
+            </a:outerShdw>
+          </a:effectLst>
+        </p:spPr>
+        <p:txBody>
+          <a:bodyPr wrap="square" lIns="127000" tIns="203200" rIns="203200" bIns="127000" rtlCol="0" anchor="ctr"/>
+          <a:lstStyle/>
+          <a:p>
+            <a:pPr indent="0" marL="0">
+              <a:buNone/>
+            </a:pPr>
+            <a:r>
+              <a:rPr lang="en-US" sz="2000" dirty="0">
+                <a:solidFill>
+                  <a:srgbClr val="3B2A20"/>
+                </a:solidFill>
+                <a:latin typeface="Arial" pitchFamily="34" charset="0"/>
+                <a:ea typeface="Arial" pitchFamily="34" charset="-122"/>
+                <a:cs typeface="Arial" pitchFamily="34" charset="-120"/>
+              </a:rPr>
+              <a:t>De un gran salto, ¡Toby la atrapó en el aire!</a:t>
+            </a:r>
+            <a:endParaRPr lang="en-US" sz="2000" dirty="0"/>
+          </a:p>
+        </p:txBody>
+      </p:sp>
+    </p:spTree>
+  </p:cSld>
+  <p:clrMapOvr>
+    <a:masterClrMapping/>
+  </p:clrMapOvr>
+  <p:transition spd="med">
+    <p:fade/>
+  </p:transition>
+  <p:timing>
+    <p:tnLst>
+      <p:par>
+        <p:cTn id="1" dur="indefinite" restart="never" nodeType="tmRoot">
+          <p:childTnLst>
+            <p:seq concurrent="1" nextAc="seek">
+              <p:cTn id="2" dur="indefinite" nodeType="mainSeq">
+                <p:childTnLst>
+                  <p:par>
+                    <p:cTn id="3" fill="hold">
+                      <p:stCondLst>
+                        <p:cond delay="indefinite"/>
+                        <p:cond evt="onBegin" delay="0">
+                          <p:tn val="2"/>
+                        </p:cond>
+                      </p:stCondLst>
+                      <p:childTnLst>
+                        <p:par>
+                          <p:cTn id="12" fill="hold">
+                            <p:stCondLst>
+                              <p:cond delay="0"/>
+                            </p:stCondLst>
+                            <p:childTnLst>
+                              <p:par>
+                                <p:cTn id="4" presetID="2" presetClass="entr" presetSubtype="4" fill="hold" grpId="0" nodeType="afterEffect">
+                                  <p:stCondLst>
+                                    <p:cond delay="0"/>
+                                  </p:stCondLst>
+                                  <p:childTnLst>
+                                    <p:set>
+                                      <p:cBhvr>
+                                        <p:cTn id="5" dur="1" fill="hold">
+                                          <p:stCondLst>
+                                            <p:cond delay="0"/>
+                                          </p:stCondLst>
+                                        </p:cTn>
+                                        <p:tgtEl>
+                                          <p:spTgt spid="4"/>
+                                        </p:tgtEl>
+                                        <p:attrNameLst>
+                                          <p:attrName>style.visibility</p:attrName>
+                                        </p:attrNameLst>
+                                      </p:cBhvr>
+                                      <p:to>
+                                        <p:strVal val="visible"/>
+                                      </p:to>
+                                    </p:set>
+                                    <p:anim calcmode="lin" valueType="num">
+                                      <p:cBhvr additive="base">
+                                        <p:cTn id="6" dur="900" fill="hold"/>
+                                        <p:tgtEl>
+                                          <p:spTgt spid="4"/>
+                                        </p:tgtEl>
+                                        <p:attrNameLst>
+                                          <p:attrName>ppt_x</p:attrName>
+                                        </p:attrNameLst>
+                                      </p:cBhvr>
+                                      <p:tavLst>
+                                        <p:tav tm="0">
+                                          <p:val>
+                                            <p:strVal val="#ppt_x"/>
+                                          </p:val>
+                                        </p:tav>
+                                        <p:tav tm="100000">
+                                          <p:val>
+                                            <p:strVal val="#ppt_x"/>
+                                          </p:val>
+                                        </p:tav>
+                                      </p:tavLst>
+                                    </p:anim>
+                                    <p:anim calcmode="lin" valueType="num">
+                                      <p:cBhvr additive="base">
+                                        <p:cTn id="7" dur="900" fill="hold"/>
+                                        <p:tgtEl>
+                                          <p:spTgt spid="4"/>
+                                        </p:tgtEl>
+                                        <p:attrNameLst>
+                                          <p:attrName>ppt_y</p:attrName>
+                                        </p:attrNameLst>
+                                      </p:cBhvr>
+                                      <p:tavLst>
+                                        <p:tav tm="0">
+                                          <p:val>
+                                            <p:strVal val="1+#ppt_h/2"/>
+                                          </p:val>
+                                        </p:tav>
+                                        <p:tav tm="100000">
+                                          <p:val>
+                                            <p:strVal val="#ppt_y"/>
+                                          </p:val>
+                                        </p:tav>
+                                      </p:tavLst>
+                                    </p:anim>
+                                  </p:childTnLst>
+                                </p:cTn>
+                              </p:par>
+                              <p:par>
+                                <p:cTn id="8" presetID="2" presetClass="entr" presetSubtype="2" fill="hold" grpId="0" nodeType="withEffect">
+                                  <p:stCondLst>
+                                    <p:cond delay="0"/>
+                                  </p:stCondLst>
+                                  <p:childTnLst>
+                                    <p:set>
+                                      <p:cBhvr>
+                                        <p:cTn id="9" dur="1" fill="hold">
+                                          <p:stCondLst>
+                                            <p:cond delay="0"/>
+                                          </p:stCondLst>
+                                        </p:cTn>
+                                        <p:tgtEl>
+                                          <p:spTgt spid="3"/>
+                                        </p:tgtEl>
+                                        <p:attrNameLst>
+                                          <p:attrName>style.visibility</p:attrName>
+                                        </p:attrNameLst>
+                                      </p:cBhvr>
+                                      <p:to>
+                                        <p:strVal val="visible"/>
+                                      </p:to>
+                                    </p:set>
+                                    <p:anim calcmode="lin" valueType="num">
+                                      <p:cBhvr additive="base">
+                                        <p:cTn id="10" dur="900" fill="hold"/>
+                                        <p:tgtEl>
+                                          <p:spTgt spid="3"/>
+                                        </p:tgtEl>
+                                        <p:attrNameLst>
+                                          <p:attrName>ppt_x</p:attrName>
+                                        </p:attrNameLst>
+                                      </p:cBhvr>
+                                      <p:tavLst>
+                                        <p:tav tm="0">
+                                          <p:val>
+                                            <p:strVal val="1+#ppt_w/2"/>
+                                          </p:val>
+                                        </p:tav>
+                                        <p:tav tm="100000">
+                                          <p:val>
+                                            <p:strVal val="#ppt_x"/>
+                                          </p:val>
+                                        </p:tav>
+                                      </p:tavLst>
+                                    </p:anim>
+                                    <p:anim calcmode="lin" valueType="num">
+                                      <p:cBhvr additive="base">
+                                        <p:cTn id="11" dur="900" fill="hold"/>
+                                        <p:tgtEl>
+                                          <p:spTgt spid="3"/>
+                                        </p:tgtEl>
+                                        <p:attrNameLst>
+                                          <p:attrName>ppt_y</p:attrName>
+                                        </p:attrNameLst>
+                                      </p:cBhvr>
+                                      <p:tavLst>
+                                        <p:tav tm="0">
+                                          <p:val>
+                                            <p:strVal val="#ppt_y"/>
+                                          </p:val>
+                                        </p:tav>
+                                        <p:tav tm="100000">
+                                          <p:val>
+                                            <p:strVal val="#ppt_y"/>
+                                          </p:val>
+                                        </p:tav>
+                                      </p:tavLst>
+                                    </p:anim>
+                                  </p:childTnLst>
+                                </p:cTn>
+                              </p:par>
+                            </p:childTnLst>
+                          </p:cTn>
+                        </p:par>
+                        <p:par>
+                          <p:cTn id="16" fill="hold">
+                            <p:stCondLst>
+                              <p:cond delay="1150"/>
+                            </p:stCondLst>
+                            <p:childTnLst>
+                              <p:par>
+                                <p:cTn id="13" presetID="10" presetClass="entr" presetSubtype="0" fill="hold" grpId="0" nodeType="afterEffect">
+                                  <p:stCondLst>
+                                    <p:cond delay="0"/>
+                                  </p:stCondLst>
+                                  <p:childTnLst>
+                                    <p:set>
+                                      <p:cBhvr>
+                                        <p:cTn id="14" dur="1" fill="hold">
+                                          <p:stCondLst>
+                                            <p:cond delay="0"/>
+                                          </p:stCondLst>
+                                        </p:cTn>
+                                        <p:tgtEl>
+                                          <p:spTgt spid="6"/>
+                                        </p:tgtEl>
+                                        <p:attrNameLst>
+                                          <p:attrName>style.visibility</p:attrName>
+                                        </p:attrNameLst>
+                                      </p:cBhvr>
+                                      <p:to>
+                                        <p:strVal val="visible"/>
+                                      </p:to>
+                                    </p:set>
+                                    <p:animEffect transition="in" filter="fade">
+                                      <p:cBhvr>
+                                        <p:cTn id="15" dur="900"/>
+                                        <p:tgtEl>
+                                          <p:spTgt spid="6"/>
+                                        </p:tgtEl>
+                                      </p:cBhvr>
+                                    </p:animEffect>
+                                  </p:childTnLst>
+                                </p:cTn>
+                              </p:par>
+                            </p:childTnLst>
+                          </p:cTn>
+                        </p:par>
+                      </p:childTnLst>
+                    </p:cTn>
+                  </p:par>
+                </p:childTnLst>
+              </p:cTn>
+              <p:prevCondLst>
+                <p:cond evt="onPrev" delay="0">
+                  <p:tgtEl>
+                    <p:sldTgt/>
+                  </p:tgtEl>
+                </p:cond>
+              </p:prevCondLst>
+              <p:nextCondLst>
+                <p:cond evt="onNext" delay="0">
+                  <p:tgtEl>
+                    <p:sldTgt/>
+                  </p:tgtEl>
+                </p:cond>
+              </p:nextCondLst>
+            </p:seq>
+          </p:childTnLst>
+        </p:cTn>
+      </p:par>
+    </p:tnLst>
+    <p:bldLst>
+      <p:bldP spid="6" grpId="0" animBg="1"/>
+    </p:bldLst>
+  </p:timing>
+</p:sld>
+</file>
+
+<file path=ppt/slides/slide7.xml><?xml version="1.0" encoding="utf-8"?>
+<p:sld xmlns:a="http://schemas.openxmlformats.org/drawingml/2006/main" xmlns:r="http://schemas.openxmlformats.org/officeDocument/2006/relationships" xmlns:p="http://schemas.openxmlformats.org/presentationml/2006/main">
+  <p:cSld name="Slide 7">
     <p:bg>
       <p:bgPr>
         <a:blipFill dpi="0" rotWithShape="1">
@@ -3294,9 +4368,435 @@
 </p:sld>
 </file>
 
-<file path=ppt/slides/slide6.xml><?xml version="1.0" encoding="utf-8"?>
+<file path=ppt/slides/slide8.xml><?xml version="1.0" encoding="utf-8"?>
 <p:sld xmlns:a="http://schemas.openxmlformats.org/drawingml/2006/main" xmlns:r="http://schemas.openxmlformats.org/officeDocument/2006/relationships" xmlns:p="http://schemas.openxmlformats.org/presentationml/2006/main">
-  <p:cSld name="Slide 6">
+  <p:cSld name="Slide 8">
+    <p:bg>
+      <p:bgPr>
+        <a:blipFill dpi="0" rotWithShape="1">
+          <a:blip r:embed="rId1">
+            <a:lum/>
+          </a:blip>
+          <a:srcRect/>
+          <a:stretch>
+            <a:fillRect/>
+          </a:stretch>
+        </a:blipFill>
+        <a:effectLst/>
+      </p:bgPr>
+    </p:bg>
+    <p:spTree>
+      <p:nvGrpSpPr>
+        <p:cNvPr id="1" name=""/>
+        <p:cNvGrpSpPr/>
+        <p:nvPr/>
+      </p:nvGrpSpPr>
+      <p:grpSpPr>
+        <a:xfrm>
+          <a:off x="0" y="0"/>
+          <a:ext cx="0" cy="0"/>
+          <a:chOff x="0" y="0"/>
+          <a:chExt cx="0" cy="0"/>
+        </a:xfrm>
+      </p:grpSpPr>
+      <p:pic>
+        <p:nvPicPr>
+          <p:cNvPr id="2" name="trees" descr="Árbol y arbusto">    </p:cNvPr>
+          <p:cNvPicPr>
+            <a:picLocks noChangeAspect="1"/>
+          </p:cNvPicPr>
+          <p:nvPr/>
+        </p:nvPicPr>
+        <p:blipFill>
+          <a:blip r:embed="rId2"/>
+          <a:stretch>
+            <a:fillRect/>
+          </a:stretch>
+        </p:blipFill>
+        <p:spPr>
+          <a:xfrm>
+            <a:off x="3765744" y="0"/>
+            <a:ext cx="5194796" cy="4992025"/>
+          </a:xfrm>
+          <a:prstGeom prst="rect">
+            <a:avLst/>
+          </a:prstGeom>
+        </p:spPr>
+      </p:pic>
+      <p:pic>
+        <p:nvPicPr>
+          <p:cNvPr id="3" name="ball" descr="Pelota roja">    </p:cNvPr>
+          <p:cNvPicPr>
+            <a:picLocks noChangeAspect="1"/>
+          </p:cNvPicPr>
+          <p:nvPr/>
+        </p:nvPicPr>
+        <p:blipFill>
+          <a:blip r:embed="rId3"/>
+          <a:stretch>
+            <a:fillRect/>
+          </a:stretch>
+        </p:blipFill>
+        <p:spPr>
+          <a:xfrm>
+            <a:off x="1828800" y="4451303"/>
+            <a:ext cx="608313" cy="608313"/>
+          </a:xfrm>
+          <a:prstGeom prst="rect">
+            <a:avLst/>
+          </a:prstGeom>
+        </p:spPr>
+      </p:pic>
+      <p:pic>
+        <p:nvPicPr>
+          <p:cNvPr id="4" name="dog" descr="Toby, un perro corgi">    </p:cNvPr>
+          <p:cNvPicPr>
+            <a:picLocks noChangeAspect="1"/>
+          </p:cNvPicPr>
+          <p:nvPr/>
+        </p:nvPicPr>
+        <p:blipFill>
+          <a:blip r:embed="rId4"/>
+          <a:stretch>
+            <a:fillRect/>
+          </a:stretch>
+        </p:blipFill>
+        <p:spPr>
+          <a:xfrm>
+            <a:off x="2384971" y="1892528"/>
+            <a:ext cx="2742234" cy="3157432"/>
+          </a:xfrm>
+          <a:prstGeom prst="rect">
+            <a:avLst/>
+          </a:prstGeom>
+        </p:spPr>
+      </p:pic>
+      <p:pic>
+        <p:nvPicPr>
+          <p:cNvPr id="5" name="grass" descr="Pasto">    </p:cNvPr>
+          <p:cNvPicPr>
+            <a:picLocks noChangeAspect="1"/>
+          </p:cNvPicPr>
+          <p:nvPr/>
+        </p:nvPicPr>
+        <p:blipFill>
+          <a:blip r:embed="rId5"/>
+          <a:stretch>
+            <a:fillRect/>
+          </a:stretch>
+        </p:blipFill>
+        <p:spPr>
+          <a:xfrm>
+            <a:off x="0" y="4258188"/>
+            <a:ext cx="9144000" cy="1226281"/>
+          </a:xfrm>
+          <a:prstGeom prst="rect">
+            <a:avLst/>
+          </a:prstGeom>
+        </p:spPr>
+      </p:pic>
+      <p:sp>
+        <p:nvSpPr>
+          <p:cNvPr id="6" name="card"/>
+          <p:cNvSpPr txBox="1"/>
+          <p:nvPr/>
+        </p:nvSpPr>
+        <p:spPr>
+          <a:xfrm>
+            <a:off x="365760" y="320040"/>
+            <a:ext cx="4206240" cy="1234440"/>
+          </a:xfrm>
+          <a:prstGeom prst="roundRect">
+            <a:avLst>
+              <a:gd name="adj" fmla="val 14815"/>
+            </a:avLst>
+          </a:prstGeom>
+          <a:solidFill>
+            <a:srgbClr val="FFFFFF">
+              <a:alpha val="92000"/>
+            </a:srgbClr>
+          </a:solidFill>
+          <a:ln/>
+          <a:effectLst>
+            <a:outerShdw sx="100000" sy="100000" kx="0" ky="0" algn="bl" rotWithShape="0" blurRad="76200" dist="25400" dir="5400000">
+              <a:srgbClr val="000000">
+                <a:alpha val="18000"/>
+              </a:srgbClr>
+            </a:outerShdw>
+          </a:effectLst>
+        </p:spPr>
+        <p:txBody>
+          <a:bodyPr wrap="square" lIns="127000" tIns="203200" rIns="203200" bIns="127000" rtlCol="0" anchor="ctr"/>
+          <a:lstStyle/>
+          <a:p>
+            <a:pPr indent="0" marL="0">
+              <a:buNone/>
+            </a:pPr>
+            <a:r>
+              <a:rPr lang="en-US" sz="2000" dirty="0">
+                <a:solidFill>
+                  <a:srgbClr val="3B2A20"/>
+                </a:solidFill>
+                <a:latin typeface="Arial" pitchFamily="34" charset="0"/>
+                <a:ea typeface="Arial" pitchFamily="34" charset="-122"/>
+                <a:cs typeface="Arial" pitchFamily="34" charset="-120"/>
+              </a:rPr>
+              <a:t>Al terminar el día, Toby estaba cansado pero </a:t>
+            </a:r>
+            <a:pPr indent="0" marL="0">
+              <a:buNone/>
+            </a:pPr>
+            <a:r>
+              <a:rPr lang="en-US" sz="2000" b="1" dirty="0">
+                <a:solidFill>
+                  <a:srgbClr val="E0702A"/>
+                </a:solidFill>
+                <a:latin typeface="Arial" pitchFamily="34" charset="0"/>
+                <a:ea typeface="Arial" pitchFamily="34" charset="-122"/>
+                <a:cs typeface="Arial" pitchFamily="34" charset="-120"/>
+              </a:rPr>
+              <a:t>feliz y lleno de energía</a:t>
+            </a:r>
+            <a:pPr indent="0" marL="0">
+              <a:buNone/>
+            </a:pPr>
+            <a:r>
+              <a:rPr lang="en-US" sz="2000" dirty="0">
+                <a:solidFill>
+                  <a:srgbClr val="3B2A20"/>
+                </a:solidFill>
+                <a:latin typeface="Arial" pitchFamily="34" charset="0"/>
+                <a:ea typeface="Arial" pitchFamily="34" charset="-122"/>
+                <a:cs typeface="Arial" pitchFamily="34" charset="-120"/>
+              </a:rPr>
+              <a:t>.</a:t>
+            </a:r>
+            <a:endParaRPr lang="en-US" sz="2000" dirty="0"/>
+          </a:p>
+        </p:txBody>
+      </p:sp>
+      <p:sp>
+        <p:nvSpPr>
+          <p:cNvPr id="7" name="bubble"/>
+          <p:cNvSpPr txBox="1"/>
+          <p:nvPr/>
+        </p:nvSpPr>
+        <p:spPr>
+          <a:xfrm>
+            <a:off x="4572000" y="1417320"/>
+            <a:ext cx="2743200" cy="777240"/>
+          </a:xfrm>
+          <a:prstGeom prst="ellipse">
+            <a:avLst/>
+          </a:prstGeom>
+          <a:solidFill>
+            <a:srgbClr val="FFFFFF"/>
+          </a:solidFill>
+          <a:ln w="25400">
+            <a:solidFill>
+              <a:srgbClr val="E0702A"/>
+            </a:solidFill>
+          </a:ln>
+        </p:spPr>
+        <p:txBody>
+          <a:bodyPr wrap="square" rtlCol="0" anchor="ctr"/>
+          <a:lstStyle/>
+          <a:p>
+            <a:pPr algn="ctr" indent="0" marL="0">
+              <a:buNone/>
+            </a:pPr>
+            <a:r>
+              <a:rPr lang="en-US" sz="2000" b="1" dirty="0">
+                <a:solidFill>
+                  <a:srgbClr val="E0702A"/>
+                </a:solidFill>
+                <a:latin typeface="Arial" pitchFamily="34" charset="0"/>
+                <a:ea typeface="Arial" pitchFamily="34" charset="-122"/>
+                <a:cs typeface="Arial" pitchFamily="34" charset="-120"/>
+              </a:rPr>
+              <a:t>¡Qué divertido!</a:t>
+            </a:r>
+            <a:endParaRPr lang="en-US" sz="2000" dirty="0"/>
+          </a:p>
+        </p:txBody>
+      </p:sp>
+    </p:spTree>
+  </p:cSld>
+  <p:clrMapOvr>
+    <a:masterClrMapping/>
+  </p:clrMapOvr>
+  <p:transition spd="med">
+    <p:fade/>
+  </p:transition>
+  <p:timing>
+    <p:tnLst>
+      <p:par>
+        <p:cTn id="1" dur="indefinite" restart="never" nodeType="tmRoot">
+          <p:childTnLst>
+            <p:seq concurrent="1" nextAc="seek">
+              <p:cTn id="2" dur="indefinite" nodeType="mainSeq">
+                <p:childTnLst>
+                  <p:par>
+                    <p:cTn id="3" fill="hold">
+                      <p:stCondLst>
+                        <p:cond delay="indefinite"/>
+                        <p:cond evt="onBegin" delay="0">
+                          <p:tn val="2"/>
+                        </p:cond>
+                      </p:stCondLst>
+                      <p:childTnLst>
+                        <p:par>
+                          <p:cTn id="7" fill="hold">
+                            <p:stCondLst>
+                              <p:cond delay="0"/>
+                            </p:stCondLst>
+                            <p:childTnLst>
+                              <p:par>
+                                <p:cTn id="4" presetID="10" presetClass="entr" presetSubtype="0" fill="hold" grpId="0" nodeType="afterEffect">
+                                  <p:stCondLst>
+                                    <p:cond delay="0"/>
+                                  </p:stCondLst>
+                                  <p:childTnLst>
+                                    <p:set>
+                                      <p:cBhvr>
+                                        <p:cTn id="5" dur="1" fill="hold">
+                                          <p:stCondLst>
+                                            <p:cond delay="0"/>
+                                          </p:stCondLst>
+                                        </p:cTn>
+                                        <p:tgtEl>
+                                          <p:spTgt spid="6"/>
+                                        </p:tgtEl>
+                                        <p:attrNameLst>
+                                          <p:attrName>style.visibility</p:attrName>
+                                        </p:attrNameLst>
+                                      </p:cBhvr>
+                                      <p:to>
+                                        <p:strVal val="visible"/>
+                                      </p:to>
+                                    </p:set>
+                                    <p:animEffect transition="in" filter="fade">
+                                      <p:cBhvr>
+                                        <p:cTn id="6" dur="900"/>
+                                        <p:tgtEl>
+                                          <p:spTgt spid="6"/>
+                                        </p:tgtEl>
+                                      </p:cBhvr>
+                                    </p:animEffect>
+                                  </p:childTnLst>
+                                </p:cTn>
+                              </p:par>
+                            </p:childTnLst>
+                          </p:cTn>
+                        </p:par>
+                        <p:par>
+                          <p:cTn id="11" fill="hold">
+                            <p:stCondLst>
+                              <p:cond delay="1150"/>
+                            </p:stCondLst>
+                            <p:childTnLst>
+                              <p:par>
+                                <p:cTn id="8" presetID="10" presetClass="entr" presetSubtype="0" fill="hold" grpId="0" nodeType="afterEffect">
+                                  <p:stCondLst>
+                                    <p:cond delay="0"/>
+                                  </p:stCondLst>
+                                  <p:childTnLst>
+                                    <p:set>
+                                      <p:cBhvr>
+                                        <p:cTn id="9" dur="1" fill="hold">
+                                          <p:stCondLst>
+                                            <p:cond delay="0"/>
+                                          </p:stCondLst>
+                                        </p:cTn>
+                                        <p:tgtEl>
+                                          <p:spTgt spid="7"/>
+                                        </p:tgtEl>
+                                        <p:attrNameLst>
+                                          <p:attrName>style.visibility</p:attrName>
+                                        </p:attrNameLst>
+                                      </p:cBhvr>
+                                      <p:to>
+                                        <p:strVal val="visible"/>
+                                      </p:to>
+                                    </p:set>
+                                    <p:animEffect transition="in" filter="fade">
+                                      <p:cBhvr>
+                                        <p:cTn id="10" dur="700"/>
+                                        <p:tgtEl>
+                                          <p:spTgt spid="7"/>
+                                        </p:tgtEl>
+                                      </p:cBhvr>
+                                    </p:animEffect>
+                                  </p:childTnLst>
+                                </p:cTn>
+                              </p:par>
+                            </p:childTnLst>
+                          </p:cTn>
+                        </p:par>
+                        <p:par>
+                          <p:cTn id="14" fill="hold">
+                            <p:stCondLst>
+                              <p:cond delay="2100"/>
+                            </p:stCondLst>
+                            <p:childTnLst>
+                              <p:par>
+                                <p:cTn id="12" presetID="8" presetClass="emph" presetSubtype="0" fill="hold" grpId="0" nodeType="afterEffect">
+                                  <p:stCondLst>
+                                    <p:cond delay="0"/>
+                                  </p:stCondLst>
+                                  <p:childTnLst>
+                                    <p:animRot by="21600000">
+                                      <p:cBhvr>
+                                        <p:cTn id="13" dur="900" fill="hold"/>
+                                        <p:tgtEl>
+                                          <p:spTgt spid="3"/>
+                                        </p:tgtEl>
+                                        <p:attrNameLst>
+                                          <p:attrName>r</p:attrName>
+                                        </p:attrNameLst>
+                                      </p:cBhvr>
+                                    </p:animRot>
+                                  </p:childTnLst>
+                                </p:cTn>
+                              </p:par>
+                            </p:childTnLst>
+                          </p:cTn>
+                        </p:par>
+                      </p:childTnLst>
+                    </p:cTn>
+                  </p:par>
+                </p:childTnLst>
+              </p:cTn>
+              <p:prevCondLst>
+                <p:cond evt="onPrev" delay="0">
+                  <p:tgtEl>
+                    <p:sldTgt/>
+                  </p:tgtEl>
+                </p:cond>
+              </p:prevCondLst>
+              <p:nextCondLst>
+                <p:cond evt="onNext" delay="0">
+                  <p:tgtEl>
+                    <p:sldTgt/>
+                  </p:tgtEl>
+                </p:cond>
+              </p:nextCondLst>
+            </p:seq>
+          </p:childTnLst>
+        </p:cTn>
+      </p:par>
+    </p:tnLst>
+    <p:bldLst>
+      <p:bldP spid="6" grpId="0" animBg="1"/>
+      <p:bldP spid="7" grpId="0" animBg="1"/>
+    </p:bldLst>
+  </p:timing>
+</p:sld>
+</file>
+
+<file path=ppt/slides/slide9.xml><?xml version="1.0" encoding="utf-8"?>
+<p:sld xmlns:a="http://schemas.openxmlformats.org/drawingml/2006/main" xmlns:r="http://schemas.openxmlformats.org/officeDocument/2006/relationships" xmlns:p="http://schemas.openxmlformats.org/presentationml/2006/main">
+  <p:cSld name="Slide 9">
     <p:bg>
       <p:bgPr>
         <a:blipFill dpi="0" rotWithShape="1">

</xml_diff>